<commit_message>
feat(enh040): vp-proposal quality uplift → 2.7.0 (phase 69)
Layer 1 — .pptx: 5 distinct layouts (cover/section/two-column/data/closing);
  regenerated 4 stock templates (137–151 KB)
Layer 2 — AI: prompt contract with 8–15 word bullets, 3–5 sentence notes,
  concrete CTA; no filler phrases
Layer 3 — .docx: Timeline table (Phase|Milestone|Duration|Deps),
  Budget table (Line Item|Estimate|Notes), Team table, narrative paragraphs;
  regenerated project-detail.docx
Layer 4 — Workflow: Step 2C quality brief (CTA, budget, timeline,
  decision-maker → manifest meta field)

Tests: 690 passing (+29 new: vp-enh040-proposal-quality + contracts)

Co-Authored-By: Claude Sonnet 4.6 <noreply@anthropic.com>
</commit_message>
<xml_diff>
--- a/templates/proposal/pptx/general.pptx
+++ b/templates/proposal/pptx/general.pptx
@@ -1229,8 +1229,8 @@
         </p:nvSpPr>
         <p:spPr>
           <a:xfrm>
-            <a:off x="0" y="6217920"/>
-            <a:ext cx="12192000" cy="73152"/>
+            <a:off x="0" y="6565392"/>
+            <a:ext cx="12192000" cy="54864"/>
           </a:xfrm>
           <a:prstGeom prst="rect">
             <a:avLst/>
@@ -1249,8 +1249,8 @@
         </p:nvSpPr>
         <p:spPr>
           <a:xfrm>
-            <a:off x="274320" y="6291072"/>
-            <a:ext cx="1828800" cy="182880"/>
+            <a:off x="274320" y="6620256"/>
+            <a:ext cx="1828800" cy="201168"/>
           </a:xfrm>
           <a:prstGeom prst="rect">
             <a:avLst/>
@@ -1266,14 +1266,56 @@
               <a:buNone/>
             </a:pPr>
             <a:r>
-              <a:rPr lang="en-US" sz="900" dirty="0">
+              <a:rPr lang="en-US" sz="800" dirty="0">
                 <a:solidFill>
                   <a:srgbClr val="8892B0"/>
                 </a:solidFill>
+                <a:latin typeface="Calibri" pitchFamily="34" charset="0"/>
+                <a:ea typeface="Calibri" pitchFamily="34" charset="-122"/>
+                <a:cs typeface="Calibri" pitchFamily="34" charset="-120"/>
               </a:rPr>
               <a:t>ViePilot</a:t>
             </a:r>
-            <a:endParaRPr lang="en-US" sz="900" dirty="0"/>
+            <a:endParaRPr lang="en-US" sz="800" dirty="0"/>
+          </a:p>
+        </p:txBody>
+      </p:sp>
+      <p:sp>
+        <p:nvSpPr>
+          <p:cNvPr id="4" name="Text 2"/>
+          <p:cNvSpPr/>
+          <p:nvPr/>
+        </p:nvSpPr>
+        <p:spPr>
+          <a:xfrm>
+            <a:off x="10515600" y="6620256"/>
+            <a:ext cx="1371600" cy="201168"/>
+          </a:xfrm>
+          <a:prstGeom prst="rect">
+            <a:avLst/>
+          </a:prstGeom>
+          <a:noFill/>
+          <a:ln/>
+        </p:spPr>
+        <p:txBody>
+          <a:bodyPr wrap="square" rtlCol="0" anchor="ctr"/>
+          <a:lstStyle/>
+          <a:p>
+            <a:pPr algn="r" indent="0" marL="0">
+              <a:buNone/>
+            </a:pPr>
+            <a:r>
+              <a:rPr lang="en-US" sz="800" dirty="0">
+                <a:solidFill>
+                  <a:srgbClr val="5A637A"/>
+                </a:solidFill>
+                <a:latin typeface="Calibri" pitchFamily="34" charset="0"/>
+                <a:ea typeface="Calibri" pitchFamily="34" charset="-122"/>
+                <a:cs typeface="Calibri" pitchFamily="34" charset="-120"/>
+              </a:rPr>
+              <a:t>·</a:t>
+            </a:r>
+            <a:endParaRPr lang="en-US" sz="800" dirty="0"/>
           </a:p>
         </p:txBody>
       </p:sp>
@@ -1588,8 +1630,28 @@
         </p:nvSpPr>
         <p:spPr>
           <a:xfrm>
-            <a:off x="0" y="1645920"/>
-            <a:ext cx="109728" cy="2194560"/>
+            <a:off x="0" y="0"/>
+            <a:ext cx="4754880" cy="6858000"/>
+          </a:xfrm>
+          <a:prstGeom prst="rect">
+            <a:avLst/>
+          </a:prstGeom>
+          <a:solidFill>
+            <a:srgbClr val="2D3142"/>
+          </a:solidFill>
+          <a:ln/>
+        </p:spPr>
+      </p:sp>
+      <p:sp>
+        <p:nvSpPr>
+          <p:cNvPr id="3" name="Shape 1"/>
+          <p:cNvSpPr/>
+          <p:nvPr/>
+        </p:nvSpPr>
+        <p:spPr>
+          <a:xfrm>
+            <a:off x="0" y="0"/>
+            <a:ext cx="182880" cy="6858000"/>
           </a:xfrm>
           <a:prstGeom prst="rect">
             <a:avLst/>
@@ -1602,14 +1664,34 @@
       </p:sp>
       <p:sp>
         <p:nvSpPr>
-          <p:cNvPr id="3" name="Text 1"/>
-          <p:cNvSpPr/>
-          <p:nvPr/>
-        </p:nvSpPr>
-        <p:spPr>
-          <a:xfrm>
-            <a:off x="365760" y="1737360"/>
-            <a:ext cx="10607040" cy="1097280"/>
+          <p:cNvPr id="4" name="Shape 2"/>
+          <p:cNvSpPr/>
+          <p:nvPr/>
+        </p:nvSpPr>
+        <p:spPr>
+          <a:xfrm>
+            <a:off x="4937760" y="2560320"/>
+            <a:ext cx="7040880" cy="45720"/>
+          </a:xfrm>
+          <a:prstGeom prst="rect">
+            <a:avLst/>
+          </a:prstGeom>
+          <a:solidFill>
+            <a:srgbClr val="4F6EF7"/>
+          </a:solidFill>
+          <a:ln/>
+        </p:spPr>
+      </p:sp>
+      <p:sp>
+        <p:nvSpPr>
+          <p:cNvPr id="5" name="Text 3"/>
+          <p:cNvSpPr/>
+          <p:nvPr/>
+        </p:nvSpPr>
+        <p:spPr>
+          <a:xfrm>
+            <a:off x="5120640" y="457200"/>
+            <a:ext cx="6766560" cy="365760"/>
           </a:xfrm>
           <a:prstGeom prst="rect">
             <a:avLst/>
@@ -1625,30 +1707,30 @@
               <a:buNone/>
             </a:pPr>
             <a:r>
-              <a:rPr lang="en-US" sz="4000" b="1" dirty="0">
-                <a:solidFill>
-                  <a:srgbClr val="E8ECF4"/>
-                </a:solidFill>
-                <a:latin typeface="Calibri" pitchFamily="34" charset="0"/>
-                <a:ea typeface="Calibri" pitchFamily="34" charset="-122"/>
-                <a:cs typeface="Calibri" pitchFamily="34" charset="-120"/>
-              </a:rPr>
-              <a:t>{{Proposal Title}}</a:t>
-            </a:r>
-            <a:endParaRPr lang="en-US" sz="4000" dirty="0"/>
-          </a:p>
-        </p:txBody>
-      </p:sp>
-      <p:sp>
-        <p:nvSpPr>
-          <p:cNvPr id="4" name="Text 2"/>
-          <p:cNvSpPr/>
-          <p:nvPr/>
-        </p:nvSpPr>
-        <p:spPr>
-          <a:xfrm>
-            <a:off x="365760" y="2926080"/>
-            <a:ext cx="8229600" cy="640080"/>
+              <a:rPr lang="en-US" sz="1100" b="1" spc="300" kern="0" dirty="0">
+                <a:solidFill>
+                  <a:srgbClr val="4F6EF7"/>
+                </a:solidFill>
+                <a:latin typeface="Calibri" pitchFamily="34" charset="0"/>
+                <a:ea typeface="Calibri" pitchFamily="34" charset="-122"/>
+                <a:cs typeface="Calibri" pitchFamily="34" charset="-120"/>
+              </a:rPr>
+              <a:t>PROPOSAL</a:t>
+            </a:r>
+            <a:endParaRPr lang="en-US" sz="1100" dirty="0"/>
+          </a:p>
+        </p:txBody>
+      </p:sp>
+      <p:sp>
+        <p:nvSpPr>
+          <p:cNvPr id="6" name="Text 4"/>
+          <p:cNvSpPr/>
+          <p:nvPr/>
+        </p:nvSpPr>
+        <p:spPr>
+          <a:xfrm>
+            <a:off x="4937760" y="1005840"/>
+            <a:ext cx="7040880" cy="1645920"/>
           </a:xfrm>
           <a:prstGeom prst="rect">
             <a:avLst/>
@@ -1664,30 +1746,30 @@
               <a:buNone/>
             </a:pPr>
             <a:r>
-              <a:rPr lang="en-US" sz="2000" dirty="0">
-                <a:solidFill>
-                  <a:srgbClr val="8892B0"/>
-                </a:solidFill>
-                <a:latin typeface="Calibri" pitchFamily="34" charset="0"/>
-                <a:ea typeface="Calibri" pitchFamily="34" charset="-122"/>
-                <a:cs typeface="Calibri" pitchFamily="34" charset="-120"/>
-              </a:rPr>
-              <a:t>{{Organisation}} · {{Date}}</a:t>
-            </a:r>
-            <a:endParaRPr lang="en-US" sz="2000" dirty="0"/>
-          </a:p>
-        </p:txBody>
-      </p:sp>
-      <p:sp>
-        <p:nvSpPr>
-          <p:cNvPr id="5" name="Text 3"/>
-          <p:cNvSpPr/>
-          <p:nvPr/>
-        </p:nvSpPr>
-        <p:spPr>
-          <a:xfrm>
-            <a:off x="365760" y="3840480"/>
-            <a:ext cx="5486400" cy="320040"/>
+              <a:rPr lang="en-US" sz="3400" b="1" dirty="0">
+                <a:solidFill>
+                  <a:srgbClr val="E8ECF4"/>
+                </a:solidFill>
+                <a:latin typeface="Calibri" pitchFamily="34" charset="0"/>
+                <a:ea typeface="Calibri" pitchFamily="34" charset="-122"/>
+                <a:cs typeface="Calibri" pitchFamily="34" charset="-120"/>
+              </a:rPr>
+              <a:t>{{Proposal Title}}</a:t>
+            </a:r>
+            <a:endParaRPr lang="en-US" sz="3400" dirty="0"/>
+          </a:p>
+        </p:txBody>
+      </p:sp>
+      <p:sp>
+        <p:nvSpPr>
+          <p:cNvPr id="7" name="Text 5"/>
+          <p:cNvSpPr/>
+          <p:nvPr/>
+        </p:nvSpPr>
+        <p:spPr>
+          <a:xfrm>
+            <a:off x="4937760" y="2743200"/>
+            <a:ext cx="7040880" cy="822960"/>
           </a:xfrm>
           <a:prstGeom prst="rect">
             <a:avLst/>
@@ -1703,12 +1785,132 @@
               <a:buNone/>
             </a:pPr>
             <a:r>
+              <a:rPr lang="en-US" sz="1700" dirty="0">
+                <a:solidFill>
+                  <a:srgbClr val="8892B0"/>
+                </a:solidFill>
+                <a:latin typeface="Calibri" pitchFamily="34" charset="0"/>
+                <a:ea typeface="Calibri" pitchFamily="34" charset="-122"/>
+                <a:cs typeface="Calibri" pitchFamily="34" charset="-120"/>
+              </a:rPr>
+              <a:t>{{One sentence: what you are proposing and the key benefit to the audience}}</a:t>
+            </a:r>
+            <a:endParaRPr lang="en-US" sz="1700" dirty="0"/>
+          </a:p>
+        </p:txBody>
+      </p:sp>
+      <p:sp>
+        <p:nvSpPr>
+          <p:cNvPr id="8" name="Text 6"/>
+          <p:cNvSpPr/>
+          <p:nvPr/>
+        </p:nvSpPr>
+        <p:spPr>
+          <a:xfrm>
+            <a:off x="4937760" y="3749040"/>
+            <a:ext cx="7040880" cy="457200"/>
+          </a:xfrm>
+          <a:prstGeom prst="rect">
+            <a:avLst/>
+          </a:prstGeom>
+          <a:noFill/>
+          <a:ln/>
+        </p:spPr>
+        <p:txBody>
+          <a:bodyPr wrap="square" rtlCol="0" anchor="ctr"/>
+          <a:lstStyle/>
+          <a:p>
+            <a:pPr indent="0" marL="0">
+              <a:buNone/>
+            </a:pPr>
+            <a:r>
+              <a:rPr lang="en-US" sz="1200" dirty="0">
+                <a:solidFill>
+                  <a:srgbClr val="5A637A"/>
+                </a:solidFill>
+                <a:latin typeface="Calibri" pitchFamily="34" charset="0"/>
+                <a:ea typeface="Calibri" pitchFamily="34" charset="-122"/>
+                <a:cs typeface="Calibri" pitchFamily="34" charset="-120"/>
+              </a:rPr>
+              <a:t>{{Organisation}} · {{Date}}</a:t>
+            </a:r>
+            <a:endParaRPr lang="en-US" sz="1200" dirty="0"/>
+          </a:p>
+        </p:txBody>
+      </p:sp>
+      <p:sp>
+        <p:nvSpPr>
+          <p:cNvPr id="9" name="Text 7"/>
+          <p:cNvSpPr/>
+          <p:nvPr/>
+        </p:nvSpPr>
+        <p:spPr>
+          <a:xfrm>
+            <a:off x="365760" y="457200"/>
+            <a:ext cx="1097280" cy="1097280"/>
+          </a:xfrm>
+          <a:prstGeom prst="rect">
+            <a:avLst/>
+          </a:prstGeom>
+          <a:noFill/>
+          <a:ln/>
+        </p:spPr>
+        <p:txBody>
+          <a:bodyPr wrap="square" rtlCol="0" anchor="ctr"/>
+          <a:lstStyle/>
+          <a:p>
+            <a:pPr indent="0" marL="0">
+              <a:buNone/>
+            </a:pPr>
+            <a:r>
+              <a:rPr lang="en-US" sz="5600" b="1" dirty="0">
+                <a:solidFill>
+                  <a:srgbClr val="4F6EF7"/>
+                </a:solidFill>
+                <a:latin typeface="Calibri" pitchFamily="34" charset="0"/>
+                <a:ea typeface="Calibri" pitchFamily="34" charset="-122"/>
+                <a:cs typeface="Calibri" pitchFamily="34" charset="-120"/>
+              </a:rPr>
+              <a:t>V</a:t>
+            </a:r>
+            <a:endParaRPr lang="en-US" sz="5600" dirty="0"/>
+          </a:p>
+        </p:txBody>
+      </p:sp>
+      <p:sp>
+        <p:nvSpPr>
+          <p:cNvPr id="10" name="Text 8"/>
+          <p:cNvSpPr/>
+          <p:nvPr/>
+        </p:nvSpPr>
+        <p:spPr>
+          <a:xfrm>
+            <a:off x="365760" y="5943600"/>
+            <a:ext cx="4023360" cy="365760"/>
+          </a:xfrm>
+          <a:prstGeom prst="rect">
+            <a:avLst/>
+          </a:prstGeom>
+          <a:noFill/>
+          <a:ln/>
+        </p:spPr>
+        <p:txBody>
+          <a:bodyPr wrap="square" rtlCol="0" anchor="ctr"/>
+          <a:lstStyle/>
+          <a:p>
+            <a:pPr indent="0" marL="0">
+              <a:buNone/>
+            </a:pPr>
+            <a:r>
               <a:rPr lang="en-US" sz="1100" dirty="0">
                 <a:solidFill>
                   <a:srgbClr val="8892B0"/>
                 </a:solidFill>
-              </a:rPr>
-              <a:t>Prepared with ViePilot · 2026</a:t>
+                <a:latin typeface="Calibri" pitchFamily="34" charset="0"/>
+                <a:ea typeface="Calibri" pitchFamily="34" charset="-122"/>
+                <a:cs typeface="Calibri" pitchFamily="34" charset="-120"/>
+              </a:rPr>
+              <a:t>ViePilot</a:t>
             </a:r>
             <a:endParaRPr lang="en-US" sz="1100" dirty="0"/>
           </a:p>
@@ -1748,7 +1950,27 @@
         <p:spPr>
           <a:xfrm>
             <a:off x="0" y="0"/>
-            <a:ext cx="12192000" cy="1005840"/>
+            <a:ext cx="109728" cy="6858000"/>
+          </a:xfrm>
+          <a:prstGeom prst="rect">
+            <a:avLst/>
+          </a:prstGeom>
+          <a:solidFill>
+            <a:srgbClr val="4F6EF7"/>
+          </a:solidFill>
+          <a:ln/>
+        </p:spPr>
+      </p:sp>
+      <p:sp>
+        <p:nvSpPr>
+          <p:cNvPr id="3" name="Shape 1"/>
+          <p:cNvSpPr/>
+          <p:nvPr/>
+        </p:nvSpPr>
+        <p:spPr>
+          <a:xfrm>
+            <a:off x="109728" y="0"/>
+            <a:ext cx="12079224" cy="914400"/>
           </a:xfrm>
           <a:prstGeom prst="rect">
             <a:avLst/>
@@ -1761,14 +1983,14 @@
       </p:sp>
       <p:sp>
         <p:nvSpPr>
-          <p:cNvPr id="3" name="Text 1"/>
-          <p:cNvSpPr/>
-          <p:nvPr/>
-        </p:nvSpPr>
-        <p:spPr>
-          <a:xfrm>
-            <a:off x="365760" y="164592"/>
-            <a:ext cx="10607040" cy="685800"/>
+          <p:cNvPr id="4" name="Text 2"/>
+          <p:cNvSpPr/>
+          <p:nvPr/>
+        </p:nvSpPr>
+        <p:spPr>
+          <a:xfrm>
+            <a:off x="347472" y="109728"/>
+            <a:ext cx="11612880" cy="694944"/>
           </a:xfrm>
           <a:prstGeom prst="rect">
             <a:avLst/>
@@ -1784,7 +2006,7 @@
               <a:buNone/>
             </a:pPr>
             <a:r>
-              <a:rPr lang="en-US" sz="2400" b="1" dirty="0">
+              <a:rPr lang="en-US" sz="2200" b="1" dirty="0">
                 <a:solidFill>
                   <a:srgbClr val="E8ECF4"/>
                 </a:solidFill>
@@ -1794,20 +2016,20 @@
               </a:rPr>
               <a:t>Overview</a:t>
             </a:r>
-            <a:endParaRPr lang="en-US" sz="2400" dirty="0"/>
-          </a:p>
-        </p:txBody>
-      </p:sp>
-      <p:sp>
-        <p:nvSpPr>
-          <p:cNvPr id="4" name="Text 2"/>
-          <p:cNvSpPr/>
-          <p:nvPr/>
-        </p:nvSpPr>
-        <p:spPr>
-          <a:xfrm>
-            <a:off x="457200" y="1188720"/>
-            <a:ext cx="10424160" cy="4754880"/>
+            <a:endParaRPr lang="en-US" sz="2200" dirty="0"/>
+          </a:p>
+        </p:txBody>
+      </p:sp>
+      <p:sp>
+        <p:nvSpPr>
+          <p:cNvPr id="5" name="Text 3"/>
+          <p:cNvSpPr/>
+          <p:nvPr/>
+        </p:nvSpPr>
+        <p:spPr>
+          <a:xfrm>
+            <a:off x="457200" y="1097280"/>
+            <a:ext cx="11430000" cy="5212080"/>
           </a:xfrm>
           <a:prstGeom prst="rect">
             <a:avLst/>
@@ -1819,12 +2041,13 @@
           <a:bodyPr wrap="square" rtlCol="0" anchor="t"/>
           <a:lstStyle/>
           <a:p>
-            <a:pPr marL="342900" indent="-342900">
-              <a:buSzPct val="100000"/>
-              <a:buChar char="•"/>
-            </a:pPr>
-            <a:r>
-              <a:rPr lang="en-US" sz="1600" dirty="0">
+            <a:pPr>
+              <a:spcAft>
+                <a:spcPts val="800"/>
+              </a:spcAft>
+            </a:pPr>
+            <a:r>
+              <a:rPr lang="en-US" sz="1500" dirty="0">
                 <a:solidFill>
                   <a:srgbClr val="E8ECF4"/>
                 </a:solidFill>
@@ -1832,17 +2055,18 @@
                 <a:ea typeface="Calibri" pitchFamily="34" charset="-122"/>
                 <a:cs typeface="Calibri" pitchFamily="34" charset="-120"/>
               </a:rPr>
-              <a:t>{{Purpose of this proposal}}</a:t>
-            </a:r>
-            <a:endParaRPr lang="en-US" sz="1600" dirty="0"/>
-          </a:p>
-          <a:p>
-            <a:pPr marL="342900" indent="-342900">
-              <a:buSzPct val="100000"/>
-              <a:buChar char="•"/>
-            </a:pPr>
-            <a:r>
-              <a:rPr lang="en-US" sz="1600" dirty="0">
+              <a:t>{{Purpose of this proposal in one sentence: "We propose to X in order to Y"}}</a:t>
+            </a:r>
+            <a:endParaRPr lang="en-US" sz="1500" dirty="0"/>
+          </a:p>
+          <a:p>
+            <a:pPr>
+              <a:spcAft>
+                <a:spcPts val="800"/>
+              </a:spcAft>
+            </a:pPr>
+            <a:r>
+              <a:rPr lang="en-US" sz="1500" dirty="0">
                 <a:solidFill>
                   <a:srgbClr val="E8ECF4"/>
                 </a:solidFill>
@@ -1850,17 +2074,18 @@
                 <a:ea typeface="Calibri" pitchFamily="34" charset="-122"/>
                 <a:cs typeface="Calibri" pitchFamily="34" charset="-120"/>
               </a:rPr>
-              <a:t>{{Scope}}</a:t>
-            </a:r>
-            <a:endParaRPr lang="en-US" sz="1600" dirty="0"/>
-          </a:p>
-          <a:p>
-            <a:pPr marL="342900" indent="-342900">
-              <a:buSzPct val="100000"/>
-              <a:buChar char="•"/>
-            </a:pPr>
-            <a:r>
-              <a:rPr lang="en-US" sz="1600" dirty="0">
+              <a:t>{{Scope: what is covered (and what is not)}}</a:t>
+            </a:r>
+            <a:endParaRPr lang="en-US" sz="1500" dirty="0"/>
+          </a:p>
+          <a:p>
+            <a:pPr>
+              <a:spcAft>
+                <a:spcPts val="800"/>
+              </a:spcAft>
+            </a:pPr>
+            <a:r>
+              <a:rPr lang="en-US" sz="1500" dirty="0">
                 <a:solidFill>
                   <a:srgbClr val="E8ECF4"/>
                 </a:solidFill>
@@ -1868,9 +2093,9 @@
                 <a:ea typeface="Calibri" pitchFamily="34" charset="-122"/>
                 <a:cs typeface="Calibri" pitchFamily="34" charset="-120"/>
               </a:rPr>
-              <a:t>{{Expected outcomes}}</a:t>
-            </a:r>
-            <a:endParaRPr lang="en-US" sz="1600" dirty="0"/>
+              <a:t>{{Expected outcomes: 2–3 measurable benefits}}</a:t>
+            </a:r>
+            <a:endParaRPr lang="en-US" sz="1500" dirty="0"/>
           </a:p>
         </p:txBody>
       </p:sp>
@@ -1908,7 +2133,27 @@
         <p:spPr>
           <a:xfrm>
             <a:off x="0" y="0"/>
-            <a:ext cx="12192000" cy="1005840"/>
+            <a:ext cx="109728" cy="6858000"/>
+          </a:xfrm>
+          <a:prstGeom prst="rect">
+            <a:avLst/>
+          </a:prstGeom>
+          <a:solidFill>
+            <a:srgbClr val="4F6EF7"/>
+          </a:solidFill>
+          <a:ln/>
+        </p:spPr>
+      </p:sp>
+      <p:sp>
+        <p:nvSpPr>
+          <p:cNvPr id="3" name="Shape 1"/>
+          <p:cNvSpPr/>
+          <p:nvPr/>
+        </p:nvSpPr>
+        <p:spPr>
+          <a:xfrm>
+            <a:off x="109728" y="0"/>
+            <a:ext cx="12079224" cy="914400"/>
           </a:xfrm>
           <a:prstGeom prst="rect">
             <a:avLst/>
@@ -1921,14 +2166,14 @@
       </p:sp>
       <p:sp>
         <p:nvSpPr>
-          <p:cNvPr id="3" name="Text 1"/>
-          <p:cNvSpPr/>
-          <p:nvPr/>
-        </p:nvSpPr>
-        <p:spPr>
-          <a:xfrm>
-            <a:off x="365760" y="164592"/>
-            <a:ext cx="10607040" cy="685800"/>
+          <p:cNvPr id="4" name="Text 2"/>
+          <p:cNvSpPr/>
+          <p:nvPr/>
+        </p:nvSpPr>
+        <p:spPr>
+          <a:xfrm>
+            <a:off x="347472" y="109728"/>
+            <a:ext cx="11612880" cy="694944"/>
           </a:xfrm>
           <a:prstGeom prst="rect">
             <a:avLst/>
@@ -1944,7 +2189,7 @@
               <a:buNone/>
             </a:pPr>
             <a:r>
-              <a:rPr lang="en-US" sz="2400" b="1" dirty="0">
+              <a:rPr lang="en-US" sz="2200" b="1" dirty="0">
                 <a:solidFill>
                   <a:srgbClr val="E8ECF4"/>
                 </a:solidFill>
@@ -1954,20 +2199,20 @@
               </a:rPr>
               <a:t>Problem / Context</a:t>
             </a:r>
-            <a:endParaRPr lang="en-US" sz="2400" dirty="0"/>
-          </a:p>
-        </p:txBody>
-      </p:sp>
-      <p:sp>
-        <p:nvSpPr>
-          <p:cNvPr id="4" name="Text 2"/>
-          <p:cNvSpPr/>
-          <p:nvPr/>
-        </p:nvSpPr>
-        <p:spPr>
-          <a:xfrm>
-            <a:off x="457200" y="1188720"/>
-            <a:ext cx="10424160" cy="4754880"/>
+            <a:endParaRPr lang="en-US" sz="2200" dirty="0"/>
+          </a:p>
+        </p:txBody>
+      </p:sp>
+      <p:sp>
+        <p:nvSpPr>
+          <p:cNvPr id="5" name="Text 3"/>
+          <p:cNvSpPr/>
+          <p:nvPr/>
+        </p:nvSpPr>
+        <p:spPr>
+          <a:xfrm>
+            <a:off x="457200" y="1097280"/>
+            <a:ext cx="11430000" cy="5212080"/>
           </a:xfrm>
           <a:prstGeom prst="rect">
             <a:avLst/>
@@ -1979,12 +2224,13 @@
           <a:bodyPr wrap="square" rtlCol="0" anchor="t"/>
           <a:lstStyle/>
           <a:p>
-            <a:pPr marL="342900" indent="-342900">
-              <a:buSzPct val="100000"/>
-              <a:buChar char="•"/>
-            </a:pPr>
-            <a:r>
-              <a:rPr lang="en-US" sz="1600" dirty="0">
+            <a:pPr>
+              <a:spcAft>
+                <a:spcPts val="800"/>
+              </a:spcAft>
+            </a:pPr>
+            <a:r>
+              <a:rPr lang="en-US" sz="1500" dirty="0">
                 <a:solidFill>
                   <a:srgbClr val="E8ECF4"/>
                 </a:solidFill>
@@ -1992,17 +2238,18 @@
                 <a:ea typeface="Calibri" pitchFamily="34" charset="-122"/>
                 <a:cs typeface="Calibri" pitchFamily="34" charset="-120"/>
               </a:rPr>
-              <a:t>{{Background}}</a:t>
-            </a:r>
-            <a:endParaRPr lang="en-US" sz="1600" dirty="0"/>
-          </a:p>
-          <a:p>
-            <a:pPr marL="342900" indent="-342900">
-              <a:buSzPct val="100000"/>
-              <a:buChar char="•"/>
-            </a:pPr>
-            <a:r>
-              <a:rPr lang="en-US" sz="1600" dirty="0">
+              <a:t>{{Background: why this situation exists}}</a:t>
+            </a:r>
+            <a:endParaRPr lang="en-US" sz="1500" dirty="0"/>
+          </a:p>
+          <a:p>
+            <a:pPr>
+              <a:spcAft>
+                <a:spcPts val="800"/>
+              </a:spcAft>
+            </a:pPr>
+            <a:r>
+              <a:rPr lang="en-US" sz="1500" dirty="0">
                 <a:solidFill>
                   <a:srgbClr val="E8ECF4"/>
                 </a:solidFill>
@@ -2010,17 +2257,18 @@
                 <a:ea typeface="Calibri" pitchFamily="34" charset="-122"/>
                 <a:cs typeface="Calibri" pitchFamily="34" charset="-120"/>
               </a:rPr>
-              <a:t>{{Current challenges}}</a:t>
-            </a:r>
-            <a:endParaRPr lang="en-US" sz="1600" dirty="0"/>
-          </a:p>
-          <a:p>
-            <a:pPr marL="342900" indent="-342900">
-              <a:buSzPct val="100000"/>
-              <a:buChar char="•"/>
-            </a:pPr>
-            <a:r>
-              <a:rPr lang="en-US" sz="1600" dirty="0">
+              <a:t>{{Current challenge: specific, measurable if possible}}</a:t>
+            </a:r>
+            <a:endParaRPr lang="en-US" sz="1500" dirty="0"/>
+          </a:p>
+          <a:p>
+            <a:pPr>
+              <a:spcAft>
+                <a:spcPts val="800"/>
+              </a:spcAft>
+            </a:pPr>
+            <a:r>
+              <a:rPr lang="en-US" sz="1500" dirty="0">
                 <a:solidFill>
                   <a:srgbClr val="E8ECF4"/>
                 </a:solidFill>
@@ -2028,9 +2276,9 @@
                 <a:ea typeface="Calibri" pitchFamily="34" charset="-122"/>
                 <a:cs typeface="Calibri" pitchFamily="34" charset="-120"/>
               </a:rPr>
-              <a:t>{{Opportunity}}</a:t>
-            </a:r>
-            <a:endParaRPr lang="en-US" sz="1600" dirty="0"/>
+              <a:t>{{Opportunity: what becomes possible if this is addressed}}</a:t>
+            </a:r>
+            <a:endParaRPr lang="en-US" sz="1500" dirty="0"/>
           </a:p>
         </p:txBody>
       </p:sp>
@@ -2068,7 +2316,27 @@
         <p:spPr>
           <a:xfrm>
             <a:off x="0" y="0"/>
-            <a:ext cx="12192000" cy="1005840"/>
+            <a:ext cx="109728" cy="6858000"/>
+          </a:xfrm>
+          <a:prstGeom prst="rect">
+            <a:avLst/>
+          </a:prstGeom>
+          <a:solidFill>
+            <a:srgbClr val="4F6EF7"/>
+          </a:solidFill>
+          <a:ln/>
+        </p:spPr>
+      </p:sp>
+      <p:sp>
+        <p:nvSpPr>
+          <p:cNvPr id="3" name="Shape 1"/>
+          <p:cNvSpPr/>
+          <p:nvPr/>
+        </p:nvSpPr>
+        <p:spPr>
+          <a:xfrm>
+            <a:off x="109728" y="0"/>
+            <a:ext cx="12079224" cy="914400"/>
           </a:xfrm>
           <a:prstGeom prst="rect">
             <a:avLst/>
@@ -2081,14 +2349,14 @@
       </p:sp>
       <p:sp>
         <p:nvSpPr>
-          <p:cNvPr id="3" name="Text 1"/>
-          <p:cNvSpPr/>
-          <p:nvPr/>
-        </p:nvSpPr>
-        <p:spPr>
-          <a:xfrm>
-            <a:off x="365760" y="164592"/>
-            <a:ext cx="10607040" cy="685800"/>
+          <p:cNvPr id="4" name="Text 2"/>
+          <p:cNvSpPr/>
+          <p:nvPr/>
+        </p:nvSpPr>
+        <p:spPr>
+          <a:xfrm>
+            <a:off x="347472" y="109728"/>
+            <a:ext cx="11612880" cy="694944"/>
           </a:xfrm>
           <a:prstGeom prst="rect">
             <a:avLst/>
@@ -2104,7 +2372,7 @@
               <a:buNone/>
             </a:pPr>
             <a:r>
-              <a:rPr lang="en-US" sz="2400" b="1" dirty="0">
+              <a:rPr lang="en-US" sz="2200" b="1" dirty="0">
                 <a:solidFill>
                   <a:srgbClr val="E8ECF4"/>
                 </a:solidFill>
@@ -2114,20 +2382,20 @@
               </a:rPr>
               <a:t>Proposed Solution</a:t>
             </a:r>
-            <a:endParaRPr lang="en-US" sz="2400" dirty="0"/>
-          </a:p>
-        </p:txBody>
-      </p:sp>
-      <p:sp>
-        <p:nvSpPr>
-          <p:cNvPr id="4" name="Text 2"/>
-          <p:cNvSpPr/>
-          <p:nvPr/>
-        </p:nvSpPr>
-        <p:spPr>
-          <a:xfrm>
-            <a:off x="457200" y="1188720"/>
-            <a:ext cx="10424160" cy="4754880"/>
+            <a:endParaRPr lang="en-US" sz="2200" dirty="0"/>
+          </a:p>
+        </p:txBody>
+      </p:sp>
+      <p:sp>
+        <p:nvSpPr>
+          <p:cNvPr id="5" name="Text 3"/>
+          <p:cNvSpPr/>
+          <p:nvPr/>
+        </p:nvSpPr>
+        <p:spPr>
+          <a:xfrm>
+            <a:off x="457200" y="1097280"/>
+            <a:ext cx="11430000" cy="5212080"/>
           </a:xfrm>
           <a:prstGeom prst="rect">
             <a:avLst/>
@@ -2139,12 +2407,13 @@
           <a:bodyPr wrap="square" rtlCol="0" anchor="t"/>
           <a:lstStyle/>
           <a:p>
-            <a:pPr marL="342900" indent="-342900">
-              <a:buSzPct val="100000"/>
-              <a:buChar char="•"/>
-            </a:pPr>
-            <a:r>
-              <a:rPr lang="en-US" sz="1600" dirty="0">
+            <a:pPr>
+              <a:spcAft>
+                <a:spcPts val="800"/>
+              </a:spcAft>
+            </a:pPr>
+            <a:r>
+              <a:rPr lang="en-US" sz="1500" dirty="0">
                 <a:solidFill>
                   <a:srgbClr val="E8ECF4"/>
                 </a:solidFill>
@@ -2152,17 +2421,18 @@
                 <a:ea typeface="Calibri" pitchFamily="34" charset="-122"/>
                 <a:cs typeface="Calibri" pitchFamily="34" charset="-120"/>
               </a:rPr>
-              <a:t>{{What we're proposing}}</a:t>
-            </a:r>
-            <a:endParaRPr lang="en-US" sz="1600" dirty="0"/>
-          </a:p>
-          <a:p>
-            <a:pPr marL="342900" indent="-342900">
-              <a:buSzPct val="100000"/>
-              <a:buChar char="•"/>
-            </a:pPr>
-            <a:r>
-              <a:rPr lang="en-US" sz="1600" dirty="0">
+              <a:t>{{What we are proposing: specific and concrete}}</a:t>
+            </a:r>
+            <a:endParaRPr lang="en-US" sz="1500" dirty="0"/>
+          </a:p>
+          <a:p>
+            <a:pPr>
+              <a:spcAft>
+                <a:spcPts val="800"/>
+              </a:spcAft>
+            </a:pPr>
+            <a:r>
+              <a:rPr lang="en-US" sz="1500" dirty="0">
                 <a:solidFill>
                   <a:srgbClr val="E8ECF4"/>
                 </a:solidFill>
@@ -2170,17 +2440,18 @@
                 <a:ea typeface="Calibri" pitchFamily="34" charset="-122"/>
                 <a:cs typeface="Calibri" pitchFamily="34" charset="-120"/>
               </a:rPr>
-              <a:t>{{Why this approach}}</a:t>
-            </a:r>
-            <a:endParaRPr lang="en-US" sz="1600" dirty="0"/>
-          </a:p>
-          <a:p>
-            <a:pPr marL="342900" indent="-342900">
-              <a:buSzPct val="100000"/>
-              <a:buChar char="•"/>
-            </a:pPr>
-            <a:r>
-              <a:rPr lang="en-US" sz="1600" dirty="0">
+              <a:t>{{Why this approach: rationale over alternatives}}</a:t>
+            </a:r>
+            <a:endParaRPr lang="en-US" sz="1500" dirty="0"/>
+          </a:p>
+          <a:p>
+            <a:pPr>
+              <a:spcAft>
+                <a:spcPts val="800"/>
+              </a:spcAft>
+            </a:pPr>
+            <a:r>
+              <a:rPr lang="en-US" sz="1500" dirty="0">
                 <a:solidFill>
                   <a:srgbClr val="E8ECF4"/>
                 </a:solidFill>
@@ -2188,9 +2459,9 @@
                 <a:ea typeface="Calibri" pitchFamily="34" charset="-122"/>
                 <a:cs typeface="Calibri" pitchFamily="34" charset="-120"/>
               </a:rPr>
-              <a:t>{{Expected benefits}}</a:t>
-            </a:r>
-            <a:endParaRPr lang="en-US" sz="1600" dirty="0"/>
+              <a:t>{{Expected benefit: outcome-first language}}</a:t>
+            </a:r>
+            <a:endParaRPr lang="en-US" sz="1500" dirty="0"/>
           </a:p>
         </p:txBody>
       </p:sp>
@@ -2228,7 +2499,7 @@
         <p:spPr>
           <a:xfrm>
             <a:off x="0" y="0"/>
-            <a:ext cx="12192000" cy="1005840"/>
+            <a:ext cx="12192000" cy="914400"/>
           </a:xfrm>
           <a:prstGeom prst="rect">
             <a:avLst/>
@@ -2247,8 +2518,8 @@
         </p:nvSpPr>
         <p:spPr>
           <a:xfrm>
-            <a:off x="365760" y="164592"/>
-            <a:ext cx="10607040" cy="685800"/>
+            <a:off x="347472" y="109728"/>
+            <a:ext cx="11612880" cy="694944"/>
           </a:xfrm>
           <a:prstGeom prst="rect">
             <a:avLst/>
@@ -2264,7 +2535,7 @@
               <a:buNone/>
             </a:pPr>
             <a:r>
-              <a:rPr lang="en-US" sz="2400" b="1" dirty="0">
+              <a:rPr lang="en-US" sz="2200" b="1" dirty="0">
                 <a:solidFill>
                   <a:srgbClr val="E8ECF4"/>
                 </a:solidFill>
@@ -2274,20 +2545,40 @@
               </a:rPr>
               <a:t>Key Benefits</a:t>
             </a:r>
-            <a:endParaRPr lang="en-US" sz="2400" dirty="0"/>
-          </a:p>
-        </p:txBody>
-      </p:sp>
-      <p:sp>
-        <p:nvSpPr>
-          <p:cNvPr id="4" name="Text 2"/>
-          <p:cNvSpPr/>
-          <p:nvPr/>
-        </p:nvSpPr>
-        <p:spPr>
-          <a:xfrm>
-            <a:off x="457200" y="1188720"/>
-            <a:ext cx="10424160" cy="4754880"/>
+            <a:endParaRPr lang="en-US" sz="2200" dirty="0"/>
+          </a:p>
+        </p:txBody>
+      </p:sp>
+      <p:sp>
+        <p:nvSpPr>
+          <p:cNvPr id="4" name="Shape 2"/>
+          <p:cNvSpPr/>
+          <p:nvPr/>
+        </p:nvSpPr>
+        <p:spPr>
+          <a:xfrm>
+            <a:off x="5989320" y="1051560"/>
+            <a:ext cx="36576" cy="5303520"/>
+          </a:xfrm>
+          <a:prstGeom prst="rect">
+            <a:avLst/>
+          </a:prstGeom>
+          <a:solidFill>
+            <a:srgbClr val="5A637A"/>
+          </a:solidFill>
+          <a:ln/>
+        </p:spPr>
+      </p:sp>
+      <p:sp>
+        <p:nvSpPr>
+          <p:cNvPr id="5" name="Text 3"/>
+          <p:cNvSpPr/>
+          <p:nvPr/>
+        </p:nvSpPr>
+        <p:spPr>
+          <a:xfrm>
+            <a:off x="347472" y="1051560"/>
+            <a:ext cx="5486400" cy="411480"/>
           </a:xfrm>
           <a:prstGeom prst="rect">
             <a:avLst/>
@@ -2296,15 +2587,57 @@
           <a:ln/>
         </p:spPr>
         <p:txBody>
+          <a:bodyPr wrap="square" rtlCol="0" anchor="ctr"/>
+          <a:lstStyle/>
+          <a:p>
+            <a:pPr indent="0" marL="0">
+              <a:buNone/>
+            </a:pPr>
+            <a:r>
+              <a:rPr lang="en-US" sz="1300" b="1" dirty="0">
+                <a:solidFill>
+                  <a:srgbClr val="4F6EF7"/>
+                </a:solidFill>
+                <a:latin typeface="Calibri" pitchFamily="34" charset="0"/>
+                <a:ea typeface="Calibri" pitchFamily="34" charset="-122"/>
+                <a:cs typeface="Calibri" pitchFamily="34" charset="-120"/>
+              </a:rPr>
+              <a:t>Short-term (0–3 months)</a:t>
+            </a:r>
+            <a:endParaRPr lang="en-US" sz="1300" dirty="0"/>
+          </a:p>
+        </p:txBody>
+      </p:sp>
+      <p:sp>
+        <p:nvSpPr>
+          <p:cNvPr id="6" name="Text 4"/>
+          <p:cNvSpPr/>
+          <p:nvPr/>
+        </p:nvSpPr>
+        <p:spPr>
+          <a:xfrm>
+            <a:off x="347472" y="1554480"/>
+            <a:ext cx="5486400" cy="4572000"/>
+          </a:xfrm>
+          <a:prstGeom prst="rect">
+            <a:avLst/>
+          </a:prstGeom>
+          <a:noFill/>
+          <a:ln/>
+        </p:spPr>
+        <p:txBody>
           <a:bodyPr wrap="square" rtlCol="0" anchor="t"/>
           <a:lstStyle/>
           <a:p>
             <a:pPr marL="342900" indent="-342900">
+              <a:spcAft>
+                <a:spcPts val="700"/>
+              </a:spcAft>
               <a:buSzPct val="100000"/>
               <a:buChar char="•"/>
             </a:pPr>
             <a:r>
-              <a:rPr lang="en-US" sz="1600" dirty="0">
+              <a:rPr lang="en-US" sz="1400" dirty="0">
                 <a:solidFill>
                   <a:srgbClr val="E8ECF4"/>
                 </a:solidFill>
@@ -2312,17 +2645,20 @@
                 <a:ea typeface="Calibri" pitchFamily="34" charset="-122"/>
                 <a:cs typeface="Calibri" pitchFamily="34" charset="-120"/>
               </a:rPr>
-              <a:t>{{Benefit 1}}</a:t>
-            </a:r>
-            <a:endParaRPr lang="en-US" sz="1600" dirty="0"/>
+              <a:t>{{Benefit A}}</a:t>
+            </a:r>
+            <a:endParaRPr lang="en-US" sz="1400" dirty="0"/>
           </a:p>
           <a:p>
             <a:pPr marL="342900" indent="-342900">
+              <a:spcAft>
+                <a:spcPts val="700"/>
+              </a:spcAft>
               <a:buSzPct val="100000"/>
               <a:buChar char="•"/>
             </a:pPr>
             <a:r>
-              <a:rPr lang="en-US" sz="1600" dirty="0">
+              <a:rPr lang="en-US" sz="1400" dirty="0">
                 <a:solidFill>
                   <a:srgbClr val="E8ECF4"/>
                 </a:solidFill>
@@ -2330,17 +2666,20 @@
                 <a:ea typeface="Calibri" pitchFamily="34" charset="-122"/>
                 <a:cs typeface="Calibri" pitchFamily="34" charset="-120"/>
               </a:rPr>
-              <a:t>{{Benefit 2}}</a:t>
-            </a:r>
-            <a:endParaRPr lang="en-US" sz="1600" dirty="0"/>
+              <a:t>{{Benefit B}}</a:t>
+            </a:r>
+            <a:endParaRPr lang="en-US" sz="1400" dirty="0"/>
           </a:p>
           <a:p>
             <a:pPr marL="342900" indent="-342900">
+              <a:spcAft>
+                <a:spcPts val="700"/>
+              </a:spcAft>
               <a:buSzPct val="100000"/>
               <a:buChar char="•"/>
             </a:pPr>
             <a:r>
-              <a:rPr lang="en-US" sz="1600" dirty="0">
+              <a:rPr lang="en-US" sz="1400" dirty="0">
                 <a:solidFill>
                   <a:srgbClr val="E8ECF4"/>
                 </a:solidFill>
@@ -2348,9 +2687,133 @@
                 <a:ea typeface="Calibri" pitchFamily="34" charset="-122"/>
                 <a:cs typeface="Calibri" pitchFamily="34" charset="-120"/>
               </a:rPr>
-              <a:t>{{Benefit 3}}</a:t>
-            </a:r>
-            <a:endParaRPr lang="en-US" sz="1600" dirty="0"/>
+              <a:t>{{Benefit C}}</a:t>
+            </a:r>
+            <a:endParaRPr lang="en-US" sz="1400" dirty="0"/>
+          </a:p>
+        </p:txBody>
+      </p:sp>
+      <p:sp>
+        <p:nvSpPr>
+          <p:cNvPr id="7" name="Text 5"/>
+          <p:cNvSpPr/>
+          <p:nvPr/>
+        </p:nvSpPr>
+        <p:spPr>
+          <a:xfrm>
+            <a:off x="6309360" y="1051560"/>
+            <a:ext cx="5486400" cy="411480"/>
+          </a:xfrm>
+          <a:prstGeom prst="rect">
+            <a:avLst/>
+          </a:prstGeom>
+          <a:noFill/>
+          <a:ln/>
+        </p:spPr>
+        <p:txBody>
+          <a:bodyPr wrap="square" rtlCol="0" anchor="ctr"/>
+          <a:lstStyle/>
+          <a:p>
+            <a:pPr indent="0" marL="0">
+              <a:buNone/>
+            </a:pPr>
+            <a:r>
+              <a:rPr lang="en-US" sz="1300" b="1" dirty="0">
+                <a:solidFill>
+                  <a:srgbClr val="4F6EF7"/>
+                </a:solidFill>
+                <a:latin typeface="Calibri" pitchFamily="34" charset="0"/>
+                <a:ea typeface="Calibri" pitchFamily="34" charset="-122"/>
+                <a:cs typeface="Calibri" pitchFamily="34" charset="-120"/>
+              </a:rPr>
+              <a:t>Long-term (3–12 months)</a:t>
+            </a:r>
+            <a:endParaRPr lang="en-US" sz="1300" dirty="0"/>
+          </a:p>
+        </p:txBody>
+      </p:sp>
+      <p:sp>
+        <p:nvSpPr>
+          <p:cNvPr id="8" name="Text 6"/>
+          <p:cNvSpPr/>
+          <p:nvPr/>
+        </p:nvSpPr>
+        <p:spPr>
+          <a:xfrm>
+            <a:off x="6309360" y="1554480"/>
+            <a:ext cx="5486400" cy="4572000"/>
+          </a:xfrm>
+          <a:prstGeom prst="rect">
+            <a:avLst/>
+          </a:prstGeom>
+          <a:noFill/>
+          <a:ln/>
+        </p:spPr>
+        <p:txBody>
+          <a:bodyPr wrap="square" rtlCol="0" anchor="t"/>
+          <a:lstStyle/>
+          <a:p>
+            <a:pPr marL="342900" indent="-342900">
+              <a:spcAft>
+                <a:spcPts val="700"/>
+              </a:spcAft>
+              <a:buSzPct val="100000"/>
+              <a:buChar char="•"/>
+            </a:pPr>
+            <a:r>
+              <a:rPr lang="en-US" sz="1400" dirty="0">
+                <a:solidFill>
+                  <a:srgbClr val="E8ECF4"/>
+                </a:solidFill>
+                <a:latin typeface="Calibri" pitchFamily="34" charset="0"/>
+                <a:ea typeface="Calibri" pitchFamily="34" charset="-122"/>
+                <a:cs typeface="Calibri" pitchFamily="34" charset="-120"/>
+              </a:rPr>
+              <a:t>{{Benefit D}}</a:t>
+            </a:r>
+            <a:endParaRPr lang="en-US" sz="1400" dirty="0"/>
+          </a:p>
+          <a:p>
+            <a:pPr marL="342900" indent="-342900">
+              <a:spcAft>
+                <a:spcPts val="700"/>
+              </a:spcAft>
+              <a:buSzPct val="100000"/>
+              <a:buChar char="•"/>
+            </a:pPr>
+            <a:r>
+              <a:rPr lang="en-US" sz="1400" dirty="0">
+                <a:solidFill>
+                  <a:srgbClr val="E8ECF4"/>
+                </a:solidFill>
+                <a:latin typeface="Calibri" pitchFamily="34" charset="0"/>
+                <a:ea typeface="Calibri" pitchFamily="34" charset="-122"/>
+                <a:cs typeface="Calibri" pitchFamily="34" charset="-120"/>
+              </a:rPr>
+              <a:t>{{Benefit E}}</a:t>
+            </a:r>
+            <a:endParaRPr lang="en-US" sz="1400" dirty="0"/>
+          </a:p>
+          <a:p>
+            <a:pPr marL="342900" indent="-342900">
+              <a:spcAft>
+                <a:spcPts val="700"/>
+              </a:spcAft>
+              <a:buSzPct val="100000"/>
+              <a:buChar char="•"/>
+            </a:pPr>
+            <a:r>
+              <a:rPr lang="en-US" sz="1400" dirty="0">
+                <a:solidFill>
+                  <a:srgbClr val="E8ECF4"/>
+                </a:solidFill>
+                <a:latin typeface="Calibri" pitchFamily="34" charset="0"/>
+                <a:ea typeface="Calibri" pitchFamily="34" charset="-122"/>
+                <a:cs typeface="Calibri" pitchFamily="34" charset="-120"/>
+              </a:rPr>
+              <a:t>{{Benefit F}}</a:t>
+            </a:r>
+            <a:endParaRPr lang="en-US" sz="1400" dirty="0"/>
           </a:p>
         </p:txBody>
       </p:sp>
@@ -2388,7 +2851,27 @@
         <p:spPr>
           <a:xfrm>
             <a:off x="0" y="0"/>
-            <a:ext cx="12192000" cy="1005840"/>
+            <a:ext cx="109728" cy="6858000"/>
+          </a:xfrm>
+          <a:prstGeom prst="rect">
+            <a:avLst/>
+          </a:prstGeom>
+          <a:solidFill>
+            <a:srgbClr val="4F6EF7"/>
+          </a:solidFill>
+          <a:ln/>
+        </p:spPr>
+      </p:sp>
+      <p:sp>
+        <p:nvSpPr>
+          <p:cNvPr id="3" name="Shape 1"/>
+          <p:cNvSpPr/>
+          <p:nvPr/>
+        </p:nvSpPr>
+        <p:spPr>
+          <a:xfrm>
+            <a:off x="109728" y="0"/>
+            <a:ext cx="12079224" cy="914400"/>
           </a:xfrm>
           <a:prstGeom prst="rect">
             <a:avLst/>
@@ -2401,14 +2884,14 @@
       </p:sp>
       <p:sp>
         <p:nvSpPr>
-          <p:cNvPr id="3" name="Text 1"/>
-          <p:cNvSpPr/>
-          <p:nvPr/>
-        </p:nvSpPr>
-        <p:spPr>
-          <a:xfrm>
-            <a:off x="365760" y="164592"/>
-            <a:ext cx="10607040" cy="685800"/>
+          <p:cNvPr id="4" name="Text 2"/>
+          <p:cNvSpPr/>
+          <p:nvPr/>
+        </p:nvSpPr>
+        <p:spPr>
+          <a:xfrm>
+            <a:off x="347472" y="109728"/>
+            <a:ext cx="11612880" cy="694944"/>
           </a:xfrm>
           <a:prstGeom prst="rect">
             <a:avLst/>
@@ -2424,7 +2907,7 @@
               <a:buNone/>
             </a:pPr>
             <a:r>
-              <a:rPr lang="en-US" sz="2400" b="1" dirty="0">
+              <a:rPr lang="en-US" sz="2200" b="1" dirty="0">
                 <a:solidFill>
                   <a:srgbClr val="E8ECF4"/>
                 </a:solidFill>
@@ -2434,20 +2917,20 @@
               </a:rPr>
               <a:t>Approach &amp; Timeline</a:t>
             </a:r>
-            <a:endParaRPr lang="en-US" sz="2400" dirty="0"/>
-          </a:p>
-        </p:txBody>
-      </p:sp>
-      <p:sp>
-        <p:nvSpPr>
-          <p:cNvPr id="4" name="Text 2"/>
-          <p:cNvSpPr/>
-          <p:nvPr/>
-        </p:nvSpPr>
-        <p:spPr>
-          <a:xfrm>
-            <a:off x="457200" y="1188720"/>
-            <a:ext cx="10424160" cy="4754880"/>
+            <a:endParaRPr lang="en-US" sz="2200" dirty="0"/>
+          </a:p>
+        </p:txBody>
+      </p:sp>
+      <p:sp>
+        <p:nvSpPr>
+          <p:cNvPr id="5" name="Text 3"/>
+          <p:cNvSpPr/>
+          <p:nvPr/>
+        </p:nvSpPr>
+        <p:spPr>
+          <a:xfrm>
+            <a:off x="457200" y="1097280"/>
+            <a:ext cx="11430000" cy="5212080"/>
           </a:xfrm>
           <a:prstGeom prst="rect">
             <a:avLst/>
@@ -2459,12 +2942,13 @@
           <a:bodyPr wrap="square" rtlCol="0" anchor="t"/>
           <a:lstStyle/>
           <a:p>
-            <a:pPr marL="342900" indent="-342900">
-              <a:buSzPct val="100000"/>
-              <a:buChar char="•"/>
-            </a:pPr>
-            <a:r>
-              <a:rPr lang="en-US" sz="1600" dirty="0">
+            <a:pPr>
+              <a:spcAft>
+                <a:spcPts val="800"/>
+              </a:spcAft>
+            </a:pPr>
+            <a:r>
+              <a:rPr lang="en-US" sz="1500" dirty="0">
                 <a:solidFill>
                   <a:srgbClr val="E8ECF4"/>
                 </a:solidFill>
@@ -2472,17 +2956,18 @@
                 <a:ea typeface="Calibri" pitchFamily="34" charset="-122"/>
                 <a:cs typeface="Calibri" pitchFamily="34" charset="-120"/>
               </a:rPr>
-              <a:t>Phase 1: {{description}}</a:t>
-            </a:r>
-            <a:endParaRPr lang="en-US" sz="1600" dirty="0"/>
-          </a:p>
-          <a:p>
-            <a:pPr marL="342900" indent="-342900">
-              <a:buSzPct val="100000"/>
-              <a:buChar char="•"/>
-            </a:pPr>
-            <a:r>
-              <a:rPr lang="en-US" sz="1600" dirty="0">
+              <a:t>Phase 1 ({{duration}}): {{goal + key activities}}</a:t>
+            </a:r>
+            <a:endParaRPr lang="en-US" sz="1500" dirty="0"/>
+          </a:p>
+          <a:p>
+            <a:pPr>
+              <a:spcAft>
+                <a:spcPts val="800"/>
+              </a:spcAft>
+            </a:pPr>
+            <a:r>
+              <a:rPr lang="en-US" sz="1500" dirty="0">
                 <a:solidFill>
                   <a:srgbClr val="E8ECF4"/>
                 </a:solidFill>
@@ -2490,17 +2975,18 @@
                 <a:ea typeface="Calibri" pitchFamily="34" charset="-122"/>
                 <a:cs typeface="Calibri" pitchFamily="34" charset="-120"/>
               </a:rPr>
-              <a:t>Phase 2: {{description}}</a:t>
-            </a:r>
-            <a:endParaRPr lang="en-US" sz="1600" dirty="0"/>
-          </a:p>
-          <a:p>
-            <a:pPr marL="342900" indent="-342900">
-              <a:buSzPct val="100000"/>
-              <a:buChar char="•"/>
-            </a:pPr>
-            <a:r>
-              <a:rPr lang="en-US" sz="1600" dirty="0">
+              <a:t>Phase 2 ({{duration}}): {{goal + key activities}}</a:t>
+            </a:r>
+            <a:endParaRPr lang="en-US" sz="1500" dirty="0"/>
+          </a:p>
+          <a:p>
+            <a:pPr>
+              <a:spcAft>
+                <a:spcPts val="800"/>
+              </a:spcAft>
+            </a:pPr>
+            <a:r>
+              <a:rPr lang="en-US" sz="1500" dirty="0">
                 <a:solidFill>
                   <a:srgbClr val="E8ECF4"/>
                 </a:solidFill>
@@ -2508,9 +2994,9 @@
                 <a:ea typeface="Calibri" pitchFamily="34" charset="-122"/>
                 <a:cs typeface="Calibri" pitchFamily="34" charset="-120"/>
               </a:rPr>
-              <a:t>Estimated duration: {{timeframe}}</a:t>
-            </a:r>
-            <a:endParaRPr lang="en-US" sz="1600" dirty="0"/>
+              <a:t>Phase 3 ({{duration}}): {{goal + delivery}}</a:t>
+            </a:r>
+            <a:endParaRPr lang="en-US" sz="1500" dirty="0"/>
           </a:p>
         </p:txBody>
       </p:sp>
@@ -2548,7 +3034,27 @@
         <p:spPr>
           <a:xfrm>
             <a:off x="0" y="0"/>
-            <a:ext cx="12192000" cy="1005840"/>
+            <a:ext cx="109728" cy="6858000"/>
+          </a:xfrm>
+          <a:prstGeom prst="rect">
+            <a:avLst/>
+          </a:prstGeom>
+          <a:solidFill>
+            <a:srgbClr val="4F6EF7"/>
+          </a:solidFill>
+          <a:ln/>
+        </p:spPr>
+      </p:sp>
+      <p:sp>
+        <p:nvSpPr>
+          <p:cNvPr id="3" name="Shape 1"/>
+          <p:cNvSpPr/>
+          <p:nvPr/>
+        </p:nvSpPr>
+        <p:spPr>
+          <a:xfrm>
+            <a:off x="109728" y="0"/>
+            <a:ext cx="12079224" cy="914400"/>
           </a:xfrm>
           <a:prstGeom prst="rect">
             <a:avLst/>
@@ -2561,14 +3067,14 @@
       </p:sp>
       <p:sp>
         <p:nvSpPr>
-          <p:cNvPr id="3" name="Text 1"/>
-          <p:cNvSpPr/>
-          <p:nvPr/>
-        </p:nvSpPr>
-        <p:spPr>
-          <a:xfrm>
-            <a:off x="365760" y="164592"/>
-            <a:ext cx="10607040" cy="685800"/>
+          <p:cNvPr id="4" name="Text 2"/>
+          <p:cNvSpPr/>
+          <p:nvPr/>
+        </p:nvSpPr>
+        <p:spPr>
+          <a:xfrm>
+            <a:off x="347472" y="109728"/>
+            <a:ext cx="11612880" cy="694944"/>
           </a:xfrm>
           <a:prstGeom prst="rect">
             <a:avLst/>
@@ -2584,7 +3090,7 @@
               <a:buNone/>
             </a:pPr>
             <a:r>
-              <a:rPr lang="en-US" sz="2400" b="1" dirty="0">
+              <a:rPr lang="en-US" sz="2200" b="1" dirty="0">
                 <a:solidFill>
                   <a:srgbClr val="E8ECF4"/>
                 </a:solidFill>
@@ -2592,22 +3098,22 @@
                 <a:ea typeface="Calibri" pitchFamily="34" charset="-122"/>
                 <a:cs typeface="Calibri" pitchFamily="34" charset="-120"/>
               </a:rPr>
-              <a:t>About Us</a:t>
-            </a:r>
-            <a:endParaRPr lang="en-US" sz="2400" dirty="0"/>
-          </a:p>
-        </p:txBody>
-      </p:sp>
-      <p:sp>
-        <p:nvSpPr>
-          <p:cNvPr id="4" name="Text 2"/>
-          <p:cNvSpPr/>
-          <p:nvPr/>
-        </p:nvSpPr>
-        <p:spPr>
-          <a:xfrm>
-            <a:off x="457200" y="1188720"/>
-            <a:ext cx="10424160" cy="4754880"/>
+              <a:t>About Us / Credentials</a:t>
+            </a:r>
+            <a:endParaRPr lang="en-US" sz="2200" dirty="0"/>
+          </a:p>
+        </p:txBody>
+      </p:sp>
+      <p:sp>
+        <p:nvSpPr>
+          <p:cNvPr id="5" name="Text 3"/>
+          <p:cNvSpPr/>
+          <p:nvPr/>
+        </p:nvSpPr>
+        <p:spPr>
+          <a:xfrm>
+            <a:off x="457200" y="1097280"/>
+            <a:ext cx="11430000" cy="5212080"/>
           </a:xfrm>
           <a:prstGeom prst="rect">
             <a:avLst/>
@@ -2619,12 +3125,13 @@
           <a:bodyPr wrap="square" rtlCol="0" anchor="t"/>
           <a:lstStyle/>
           <a:p>
-            <a:pPr marL="342900" indent="-342900">
-              <a:buSzPct val="100000"/>
-              <a:buChar char="•"/>
-            </a:pPr>
-            <a:r>
-              <a:rPr lang="en-US" sz="1600" dirty="0">
+            <a:pPr>
+              <a:spcAft>
+                <a:spcPts val="800"/>
+              </a:spcAft>
+            </a:pPr>
+            <a:r>
+              <a:rPr lang="en-US" sz="1500" dirty="0">
                 <a:solidFill>
                   <a:srgbClr val="E8ECF4"/>
                 </a:solidFill>
@@ -2632,17 +3139,18 @@
                 <a:ea typeface="Calibri" pitchFamily="34" charset="-122"/>
                 <a:cs typeface="Calibri" pitchFamily="34" charset="-120"/>
               </a:rPr>
-              <a:t>{{Organisation background}}</a:t>
-            </a:r>
-            <a:endParaRPr lang="en-US" sz="1600" dirty="0"/>
-          </a:p>
-          <a:p>
-            <a:pPr marL="342900" indent="-342900">
-              <a:buSzPct val="100000"/>
-              <a:buChar char="•"/>
-            </a:pPr>
-            <a:r>
-              <a:rPr lang="en-US" sz="1600" dirty="0">
+              <a:t>{{Organisation background: founded, mission, size}}</a:t>
+            </a:r>
+            <a:endParaRPr lang="en-US" sz="1500" dirty="0"/>
+          </a:p>
+          <a:p>
+            <a:pPr>
+              <a:spcAft>
+                <a:spcPts val="800"/>
+              </a:spcAft>
+            </a:pPr>
+            <a:r>
+              <a:rPr lang="en-US" sz="1500" dirty="0">
                 <a:solidFill>
                   <a:srgbClr val="E8ECF4"/>
                 </a:solidFill>
@@ -2650,17 +3158,18 @@
                 <a:ea typeface="Calibri" pitchFamily="34" charset="-122"/>
                 <a:cs typeface="Calibri" pitchFamily="34" charset="-120"/>
               </a:rPr>
-              <a:t>{{Relevant experience}}</a:t>
-            </a:r>
-            <a:endParaRPr lang="en-US" sz="1600" dirty="0"/>
-          </a:p>
-          <a:p>
-            <a:pPr marL="342900" indent="-342900">
-              <a:buSzPct val="100000"/>
-              <a:buChar char="•"/>
-            </a:pPr>
-            <a:r>
-              <a:rPr lang="en-US" sz="1600" dirty="0">
+              <a:t>{{Relevant experience: past project + outcome}}</a:t>
+            </a:r>
+            <a:endParaRPr lang="en-US" sz="1500" dirty="0"/>
+          </a:p>
+          <a:p>
+            <a:pPr>
+              <a:spcAft>
+                <a:spcPts val="800"/>
+              </a:spcAft>
+            </a:pPr>
+            <a:r>
+              <a:rPr lang="en-US" sz="1500" dirty="0">
                 <a:solidFill>
                   <a:srgbClr val="E8ECF4"/>
                 </a:solidFill>
@@ -2668,9 +3177,9 @@
                 <a:ea typeface="Calibri" pitchFamily="34" charset="-122"/>
                 <a:cs typeface="Calibri" pitchFamily="34" charset="-120"/>
               </a:rPr>
-              <a:t>{{Credentials / references}}</a:t>
-            </a:r>
-            <a:endParaRPr lang="en-US" sz="1600" dirty="0"/>
+              <a:t>{{Credential / reference: client name or award}}</a:t>
+            </a:r>
+            <a:endParaRPr lang="en-US" sz="1500" dirty="0"/>
           </a:p>
         </p:txBody>
       </p:sp>
@@ -2728,7 +3237,7 @@
         <p:spPr>
           <a:xfrm>
             <a:off x="0" y="0"/>
-            <a:ext cx="12192000" cy="73152"/>
+            <a:ext cx="12192000" cy="137160"/>
           </a:xfrm>
           <a:prstGeom prst="rect">
             <a:avLst/>
@@ -2741,14 +3250,34 @@
       </p:sp>
       <p:sp>
         <p:nvSpPr>
-          <p:cNvPr id="4" name="Text 2"/>
-          <p:cNvSpPr/>
-          <p:nvPr/>
-        </p:nvSpPr>
-        <p:spPr>
-          <a:xfrm>
-            <a:off x="457200" y="1371600"/>
-            <a:ext cx="10424160" cy="1280160"/>
+          <p:cNvPr id="4" name="Shape 2"/>
+          <p:cNvSpPr/>
+          <p:nvPr/>
+        </p:nvSpPr>
+        <p:spPr>
+          <a:xfrm>
+            <a:off x="0" y="6720840"/>
+            <a:ext cx="12192000" cy="137160"/>
+          </a:xfrm>
+          <a:prstGeom prst="rect">
+            <a:avLst/>
+          </a:prstGeom>
+          <a:solidFill>
+            <a:srgbClr val="4F6EF7"/>
+          </a:solidFill>
+          <a:ln/>
+        </p:spPr>
+      </p:sp>
+      <p:sp>
+        <p:nvSpPr>
+          <p:cNvPr id="5" name="Text 3"/>
+          <p:cNvSpPr/>
+          <p:nvPr/>
+        </p:nvSpPr>
+        <p:spPr>
+          <a:xfrm>
+            <a:off x="457200" y="1280160"/>
+            <a:ext cx="11338560" cy="457200"/>
           </a:xfrm>
           <a:prstGeom prst="rect">
             <a:avLst/>
@@ -2764,27 +3293,30 @@
               <a:buNone/>
             </a:pPr>
             <a:r>
-              <a:rPr lang="en-US" sz="4800" b="1" dirty="0">
-                <a:solidFill>
-                  <a:srgbClr val="FFFFFF"/>
-                </a:solidFill>
-              </a:rPr>
-              <a:t>Thank You</a:t>
-            </a:r>
-            <a:endParaRPr lang="en-US" sz="4800" dirty="0"/>
-          </a:p>
-        </p:txBody>
-      </p:sp>
-      <p:sp>
-        <p:nvSpPr>
-          <p:cNvPr id="5" name="Text 3"/>
-          <p:cNvSpPr/>
-          <p:nvPr/>
-        </p:nvSpPr>
-        <p:spPr>
-          <a:xfrm>
-            <a:off x="457200" y="2926080"/>
-            <a:ext cx="10424160" cy="731520"/>
+              <a:rPr lang="en-US" sz="1300" b="1" spc="200" kern="0" dirty="0">
+                <a:solidFill>
+                  <a:srgbClr val="4F6EF7"/>
+                </a:solidFill>
+                <a:latin typeface="Calibri" pitchFamily="34" charset="0"/>
+                <a:ea typeface="Calibri" pitchFamily="34" charset="-122"/>
+                <a:cs typeface="Calibri" pitchFamily="34" charset="-120"/>
+              </a:rPr>
+              <a:t>What's Next</a:t>
+            </a:r>
+            <a:endParaRPr lang="en-US" sz="1300" dirty="0"/>
+          </a:p>
+        </p:txBody>
+      </p:sp>
+      <p:sp>
+        <p:nvSpPr>
+          <p:cNvPr id="6" name="Text 4"/>
+          <p:cNvSpPr/>
+          <p:nvPr/>
+        </p:nvSpPr>
+        <p:spPr>
+          <a:xfrm>
+            <a:off x="914400" y="1920240"/>
+            <a:ext cx="10424160" cy="1828800"/>
           </a:xfrm>
           <a:prstGeom prst="rect">
             <a:avLst/>
@@ -2800,27 +3332,50 @@
               <a:buNone/>
             </a:pPr>
             <a:r>
-              <a:rPr lang="en-US" sz="2000" dirty="0">
-                <a:solidFill>
-                  <a:srgbClr val="8892B0"/>
-                </a:solidFill>
-              </a:rPr>
-              <a:t>We look forward to your feedback.</a:t>
-            </a:r>
-            <a:endParaRPr lang="en-US" sz="2000" dirty="0"/>
-          </a:p>
-        </p:txBody>
-      </p:sp>
-      <p:sp>
-        <p:nvSpPr>
-          <p:cNvPr id="6" name="Text 4"/>
-          <p:cNvSpPr/>
-          <p:nvPr/>
-        </p:nvSpPr>
-        <p:spPr>
-          <a:xfrm>
-            <a:off x="457200" y="3931920"/>
-            <a:ext cx="10424160" cy="365760"/>
+              <a:rPr lang="en-US" sz="3200" b="1" dirty="0">
+                <a:solidFill>
+                  <a:srgbClr val="FFFFFF"/>
+                </a:solidFill>
+                <a:latin typeface="Calibri" pitchFamily="34" charset="0"/>
+                <a:ea typeface="Calibri" pitchFamily="34" charset="-122"/>
+                <a:cs typeface="Calibri" pitchFamily="34" charset="-120"/>
+              </a:rPr>
+              <a:t>{{We look forward to your feedback and the opportunity to move forward together.}}</a:t>
+            </a:r>
+            <a:endParaRPr lang="en-US" sz="3200" dirty="0"/>
+          </a:p>
+        </p:txBody>
+      </p:sp>
+      <p:sp>
+        <p:nvSpPr>
+          <p:cNvPr id="7" name="Shape 5"/>
+          <p:cNvSpPr/>
+          <p:nvPr/>
+        </p:nvSpPr>
+        <p:spPr>
+          <a:xfrm>
+            <a:off x="4114800" y="3931920"/>
+            <a:ext cx="4023360" cy="36576"/>
+          </a:xfrm>
+          <a:prstGeom prst="rect">
+            <a:avLst/>
+          </a:prstGeom>
+          <a:solidFill>
+            <a:srgbClr val="4F6EF7"/>
+          </a:solidFill>
+          <a:ln/>
+        </p:spPr>
+      </p:sp>
+      <p:sp>
+        <p:nvSpPr>
+          <p:cNvPr id="8" name="Text 6"/>
+          <p:cNvSpPr/>
+          <p:nvPr/>
+        </p:nvSpPr>
+        <p:spPr>
+          <a:xfrm>
+            <a:off x="457200" y="4160520"/>
+            <a:ext cx="11338560" cy="411480"/>
           </a:xfrm>
           <a:prstGeom prst="rect">
             <a:avLst/>
@@ -2840,10 +3395,52 @@
                 <a:solidFill>
                   <a:srgbClr val="8892B0"/>
                 </a:solidFill>
-              </a:rPr>
-              <a:t>contact@example.com · viepilot.dev</a:t>
+                <a:latin typeface="Calibri" pitchFamily="34" charset="0"/>
+                <a:ea typeface="Calibri" pitchFamily="34" charset="-122"/>
+                <a:cs typeface="Calibri" pitchFamily="34" charset="-120"/>
+              </a:rPr>
+              <a:t>contact@example.com  ·  {{phone or website}}</a:t>
             </a:r>
             <a:endParaRPr lang="en-US" sz="1300" dirty="0"/>
+          </a:p>
+        </p:txBody>
+      </p:sp>
+      <p:sp>
+        <p:nvSpPr>
+          <p:cNvPr id="9" name="Text 7"/>
+          <p:cNvSpPr/>
+          <p:nvPr/>
+        </p:nvSpPr>
+        <p:spPr>
+          <a:xfrm>
+            <a:off x="457200" y="6035040"/>
+            <a:ext cx="11338560" cy="320040"/>
+          </a:xfrm>
+          <a:prstGeom prst="rect">
+            <a:avLst/>
+          </a:prstGeom>
+          <a:noFill/>
+          <a:ln/>
+        </p:spPr>
+        <p:txBody>
+          <a:bodyPr wrap="square" rtlCol="0" anchor="ctr"/>
+          <a:lstStyle/>
+          <a:p>
+            <a:pPr algn="ctr" indent="0" marL="0">
+              <a:buNone/>
+            </a:pPr>
+            <a:r>
+              <a:rPr lang="en-US" sz="1000" dirty="0">
+                <a:solidFill>
+                  <a:srgbClr val="5A637A"/>
+                </a:solidFill>
+                <a:latin typeface="Calibri" pitchFamily="34" charset="0"/>
+                <a:ea typeface="Calibri" pitchFamily="34" charset="-122"/>
+                <a:cs typeface="Calibri" pitchFamily="34" charset="-120"/>
+              </a:rPr>
+              <a:t>Powered by ViePilot</a:t>
+            </a:r>
+            <a:endParaRPr lang="en-US" sz="1000" dirty="0"/>
           </a:p>
         </p:txBody>
       </p:sp>

</xml_diff>